<commit_message>
Refresh forecast through World Cup quarterfinals
</commit_message>
<xml_diff>
--- a/outputs/presentations/worldcup_2026_prediction_bracket_deck.pptx
+++ b/outputs/presentations/worldcup_2026_prediction_bracket_deck.pptx
@@ -253,7 +253,7 @@
                 </a:solidFill>
                 <a:latin typeface="Aptos"/>
               </a:rPr>
-              <a:t>France</a:t>
+              <a:t>Argentina</a:t>
             </a:r>
             <a:endParaRPr lang="en-US" sz="3400"/>
           </a:p>
@@ -307,7 +307,7 @@
                 </a:solidFill>
                 <a:latin typeface="Aptos"/>
               </a:rPr>
-              <a:t>Argentina</a:t>
+              <a:t>France</a:t>
             </a:r>
             <a:endParaRPr lang="en-US" sz="2600"/>
           </a:p>
@@ -398,7 +398,7 @@
                 </a:solidFill>
                 <a:latin typeface="Aptos"/>
               </a:rPr>
-              <a:t>Built from the current notebook model: FIFA rank, host bonus, squad-depth bucket, and player-form modifier. No new API fetches were used.</a:t>
+              <a:t>Live model through M100: direct SofaScore form and match stats, human tactical reads, plus July 12 Polymarket/Kalshi priors at 0.10 weight.</a:t>
             </a:r>
             <a:endParaRPr lang="en-US" sz="1600"/>
           </a:p>
@@ -435,7 +435,7 @@
                 </a:solidFill>
                 <a:latin typeface="Aptos"/>
               </a:rPr>
-              <a:t>Generated 2026-04-30</a:t>
+              <a:t>Generated 2026-07-12</a:t>
             </a:r>
             <a:endParaRPr lang="en-US" sz="1000"/>
           </a:p>
@@ -579,7 +579,7 @@
                 </a:solidFill>
                 <a:latin typeface="Aptos"/>
               </a:rPr>
-              <a:t>- FIFA men's ranking page, April 2026 update</a:t>
+              <a:t>- FIFA schedule and bracket structure</a:t>
             </a:r>
             <a:endParaRPr lang="en-US" sz="1500"/>
           </a:p>
@@ -592,7 +592,7 @@
                 </a:solidFill>
                 <a:latin typeface="Aptos"/>
               </a:rPr>
-              <a:t>- ESPN April 2026 FIFA ranking table</a:t>
+              <a:t>- AP, FIFA, Guardian, and Opta match reporting</a:t>
             </a:r>
             <a:endParaRPr lang="en-US" sz="1500"/>
           </a:p>
@@ -605,7 +605,7 @@
                 </a:solidFill>
                 <a:latin typeface="Aptos"/>
               </a:rPr>
-              <a:t>- FIFA qualified-teams article and official schedule article</a:t>
+              <a:t>- Direct SofaScore lineups, ratings, team stats, and shot maps</a:t>
             </a:r>
             <a:endParaRPr lang="en-US" sz="1500"/>
           </a:p>
@@ -618,7 +618,7 @@
                 </a:solidFill>
                 <a:latin typeface="Aptos"/>
               </a:rPr>
-              <a:t>- Official bracket template summarized via the 2026 knockout-stage reference</a:t>
+              <a:t>- July 12 Polymarket and Kalshi public APIs</a:t>
             </a:r>
             <a:endParaRPr lang="en-US" sz="1500"/>
           </a:p>
@@ -631,7 +631,7 @@
                 </a:solidFill>
                 <a:latin typeface="Aptos"/>
               </a:rPr>
-              <a:t>- DR Congo playoff placement reporting</a:t>
+              <a:t>- Transfermarkt value snapshot</a:t>
             </a:r>
             <a:endParaRPr lang="en-US" sz="1500"/>
           </a:p>
@@ -670,7 +670,7 @@
                 </a:solidFill>
                 <a:latin typeface="Aptos"/>
               </a:rPr>
-              <a:t>- Player-form modifiers are transparent subjective inputs.</a:t>
+              <a:t>- Human tactical reads are explicit and lightly weighted.</a:t>
             </a:r>
             <a:endParaRPr lang="en-US" sz="1500"/>
           </a:p>
@@ -683,7 +683,7 @@
                 </a:solidFill>
                 <a:latin typeface="Aptos"/>
               </a:rPr>
-              <a:t>- Exact FIFA points were not used for every team.</a:t>
+              <a:t>- Market prices are snapshots, not truth.</a:t>
             </a:r>
             <a:endParaRPr lang="en-US" sz="1500"/>
           </a:p>
@@ -696,7 +696,7 @@
                 </a:solidFill>
                 <a:latin typeface="Aptos"/>
               </a:rPr>
-              <a:t>- Third-place qualification and mapping are highly sensitive.</a:t>
+              <a:t>- Transfer values and ticket prices can move.</a:t>
             </a:r>
             <a:endParaRPr lang="en-US" sz="1500"/>
           </a:p>
@@ -709,7 +709,7 @@
                 </a:solidFill>
                 <a:latin typeface="Aptos"/>
               </a:rPr>
-              <a:t>- Final squads and injuries may materially change the bracket.</a:t>
+              <a:t>- Semifinal calls remain close and sensitive to availability.</a:t>
             </a:r>
             <a:endParaRPr lang="en-US" sz="1500"/>
           </a:p>
@@ -840,7 +840,7 @@
                 </a:solidFill>
                 <a:latin typeface="Aptos"/>
               </a:rPr>
-              <a:t>Rating formula</a:t>
+              <a:t>Live rating stack</a:t>
             </a:r>
             <a:endParaRPr lang="en-US" sz="1400"/>
           </a:p>
@@ -853,7 +853,7 @@
                 </a:solidFill>
                 <a:latin typeface="Aptos"/>
               </a:rPr>
-              <a:t>100 - 0.8 x FIFA rank</a:t>
+              <a:t>FIFA-rank base</a:t>
             </a:r>
             <a:endParaRPr lang="en-US" sz="1400"/>
           </a:p>
@@ -866,7 +866,7 @@
                 </a:solidFill>
                 <a:latin typeface="Aptos"/>
               </a:rPr>
-              <a:t>+ host bonus</a:t>
+              <a:t>+ squad depth</a:t>
             </a:r>
             <a:endParaRPr lang="en-US" sz="1400"/>
           </a:p>
@@ -879,7 +879,7 @@
                 </a:solidFill>
                 <a:latin typeface="Aptos"/>
               </a:rPr>
-              <a:t>+ player-form modifier</a:t>
+              <a:t>+ direct SofaScore form</a:t>
             </a:r>
             <a:endParaRPr lang="en-US" sz="1400"/>
           </a:p>
@@ -892,7 +892,7 @@
                 </a:solidFill>
                 <a:latin typeface="Aptos"/>
               </a:rPr>
-              <a:t>+ squad-depth modifier</a:t>
+              <a:t>+ result signal</a:t>
             </a:r>
             <a:endParaRPr lang="en-US" sz="1400"/>
           </a:p>
@@ -905,6 +905,32 @@
                 </a:solidFill>
                 <a:latin typeface="Aptos"/>
               </a:rPr>
+              <a:t>+ human tactical delta</a:t>
+            </a:r>
+            <a:endParaRPr lang="en-US" sz="1400"/>
+          </a:p>
+          <a:p>
+            <a:pPr algn="l"/>
+            <a:r>
+              <a:rPr lang="en-US" sz="1400">
+                <a:solidFill>
+                  <a:srgbClr val="17384D"/>
+                </a:solidFill>
+                <a:latin typeface="Aptos"/>
+              </a:rPr>
+              <a:t>+ 0.10 market prior</a:t>
+            </a:r>
+            <a:endParaRPr lang="en-US" sz="1400"/>
+          </a:p>
+          <a:p>
+            <a:pPr algn="l"/>
+            <a:r>
+              <a:rPr lang="en-US" sz="1400">
+                <a:solidFill>
+                  <a:srgbClr val="17384D"/>
+                </a:solidFill>
+                <a:latin typeface="Aptos"/>
+              </a:rPr>
               <a:t/>
             </a:r>
             <a:endParaRPr lang="en-US" sz="1400"/>
@@ -918,46 +944,7 @@
                 </a:solidFill>
                 <a:latin typeface="Aptos"/>
               </a:rPr>
-              <a:t>Knockout probability</a:t>
-            </a:r>
-            <a:endParaRPr lang="en-US" sz="1400"/>
-          </a:p>
-          <a:p>
-            <a:pPr algn="l"/>
-            <a:r>
-              <a:rPr lang="en-US" sz="1400">
-                <a:solidFill>
-                  <a:srgbClr val="17384D"/>
-                </a:solidFill>
-                <a:latin typeface="Aptos"/>
-              </a:rPr>
-              <a:t>logistic((rating A - rating B) / 8)</a:t>
-            </a:r>
-            <a:endParaRPr lang="en-US" sz="1400"/>
-          </a:p>
-          <a:p>
-            <a:pPr algn="l"/>
-            <a:r>
-              <a:rPr lang="en-US" sz="1400">
-                <a:solidFill>
-                  <a:srgbClr val="17384D"/>
-                </a:solidFill>
-                <a:latin typeface="Aptos"/>
-              </a:rPr>
-              <a:t/>
-            </a:r>
-            <a:endParaRPr lang="en-US" sz="1400"/>
-          </a:p>
-          <a:p>
-            <a:pPr algn="l"/>
-            <a:r>
-              <a:rPr lang="en-US" sz="1400">
-                <a:solidFill>
-                  <a:srgbClr val="17384D"/>
-                </a:solidFill>
-                <a:latin typeface="Aptos"/>
-              </a:rPr>
-              <a:t>Transparent scenario model, not a betting market.</a:t>
+              <a:t>Semifinal probabilities also blend complete match-advance markets at 0.10 on the log-odds scale.</a:t>
             </a:r>
             <a:endParaRPr lang="en-US" sz="1400"/>
           </a:p>
@@ -1018,7 +1005,7 @@
                 </a:solidFill>
                 <a:latin typeface="Aptos"/>
               </a:rPr>
-              <a:t>Top-tier calls are close: France over Spain and Argentina over England are both narrow semifinal picks.</a:t>
+              <a:t>Semifinals: France over Spain (52.8%); Argentina over England (55.6%).</a:t>
             </a:r>
             <a:endParaRPr lang="en-US" sz="1400"/>
           </a:p>
@@ -1090,7 +1077,7 @@
         <p:spPr>
           <a:xfrm>
             <a:off x="502920" y="256032"/>
-            <a:ext cx="6217920" cy="411480"/>
+            <a:ext cx="7315200" cy="411480"/>
           </a:xfrm>
           <a:prstGeom prst="rect">
             <a:avLst/>
@@ -1112,7 +1099,7 @@
                 </a:solidFill>
                 <a:latin typeface="Aptos"/>
               </a:rPr>
-              <a:t>Group Stage Projection</a:t>
+              <a:t>Original Group Projection (Historical)</a:t>
             </a:r>
             <a:endParaRPr lang="en-US" sz="2400"/>
           </a:p>
@@ -1208,7 +1195,7 @@
         <p:spPr>
           <a:xfrm>
             <a:off x="502920" y="292608"/>
-            <a:ext cx="6766560" cy="411480"/>
+            <a:ext cx="8229600" cy="411480"/>
           </a:xfrm>
           <a:prstGeom prst="rect">
             <a:avLst/>
@@ -1230,7 +1217,7 @@
                 </a:solidFill>
                 <a:latin typeface="Aptos"/>
               </a:rPr>
-              <a:t>Best Third-Place Qualifiers</a:t>
+              <a:t>Original Best Third Projection (Historical)</a:t>
             </a:r>
             <a:endParaRPr lang="en-US" sz="2400"/>
           </a:p>
@@ -1734,7 +1721,7 @@
                 </a:solidFill>
                 <a:latin typeface="Aptos"/>
               </a:rPr>
-              <a:t>Projected route: France beats Spain, Argentina beats England, then France beats Argentina in the final. Spain edges England for third place.</a:t>
+              <a:t>Projected route: France beats Spain, Argentina beats England, then Argentina beats France in the final. Spain takes third place.</a:t>
             </a:r>
             <a:endParaRPr lang="en-US" sz="1700"/>
           </a:p>
@@ -1869,7 +1856,7 @@
                 </a:solidFill>
                 <a:latin typeface="Aptos"/>
               </a:rPr>
-              <a:t>Tournament variables</a:t>
+              <a:t>Semifinal variables</a:t>
             </a:r>
             <a:endParaRPr lang="en-US" sz="1700"/>
           </a:p>
@@ -1882,7 +1869,7 @@
                 </a:solidFill>
                 <a:latin typeface="Aptos"/>
               </a:rPr>
-              <a:t>- Final squads and injuries</a:t>
+              <a:t>- France pace versus Spain control</a:t>
             </a:r>
             <a:endParaRPr lang="en-US" sz="1700"/>
           </a:p>
@@ -1895,7 +1882,7 @@
                 </a:solidFill>
                 <a:latin typeface="Aptos"/>
               </a:rPr>
-              <a:t>- June 10 FIFA ranking update</a:t>
+              <a:t>- Spain finishing without a classic No. 9</a:t>
             </a:r>
             <a:endParaRPr lang="en-US" sz="1700"/>
           </a:p>
@@ -1908,7 +1895,7 @@
                 </a:solidFill>
                 <a:latin typeface="Aptos"/>
               </a:rPr>
-              <a:t>- Host-continent travel and climate</a:t>
+              <a:t>- England's adversity management</a:t>
             </a:r>
             <a:endParaRPr lang="en-US" sz="1700"/>
           </a:p>
@@ -1921,7 +1908,7 @@
                 </a:solidFill>
                 <a:latin typeface="Aptos"/>
               </a:rPr>
-              <a:t>- Third-place mapping volatility</a:t>
+              <a:t>- Argentina's defensive vulnerability</a:t>
             </a:r>
             <a:endParaRPr lang="en-US" sz="1700"/>
           </a:p>
@@ -1934,7 +1921,7 @@
                 </a:solidFill>
                 <a:latin typeface="Aptos"/>
               </a:rPr>
-              <a:t>- Penalty shootout variance</a:t>
+              <a:t>- Extra-time fatigue and recovery</a:t>
             </a:r>
             <a:endParaRPr lang="en-US" sz="1700"/>
           </a:p>
@@ -1947,7 +1934,7 @@
                 </a:solidFill>
                 <a:latin typeface="Aptos"/>
               </a:rPr>
-              <a:t>- Refereeing and game-state effects</a:t>
+              <a:t>- Penalty and refereeing variance</a:t>
             </a:r>
             <a:endParaRPr lang="en-US" sz="1700"/>
           </a:p>
@@ -2001,7 +1988,7 @@
                 </a:solidFill>
                 <a:latin typeface="Aptos"/>
               </a:rPr>
-              <a:t>- Rodri/Spain availability and minutes</a:t>
+              <a:t>- Messi workload after long matches</a:t>
             </a:r>
             <a:endParaRPr lang="en-US" sz="1700"/>
           </a:p>
@@ -2014,7 +2001,7 @@
                 </a:solidFill>
                 <a:latin typeface="Aptos"/>
               </a:rPr>
-              <a:t>- Messi/Argentina workload</a:t>
+              <a:t>- Mbappe/Dembele chance creation</a:t>
             </a:r>
             <a:endParaRPr lang="en-US" sz="1700"/>
           </a:p>
@@ -2027,7 +2014,7 @@
                 </a:solidFill>
                 <a:latin typeface="Aptos"/>
               </a:rPr>
-              <a:t>- Mbappe and France attacking form</a:t>
+              <a:t>- Bellingham's four knockout goals</a:t>
             </a:r>
             <a:endParaRPr lang="en-US" sz="1700"/>
           </a:p>
@@ -2040,7 +2027,7 @@
                 </a:solidFill>
                 <a:latin typeface="Aptos"/>
               </a:rPr>
-              <a:t>- Kane/Bellingham/Saka finishing output</a:t>
+              <a:t>- Kane's clutch finishing</a:t>
             </a:r>
             <a:endParaRPr lang="en-US" sz="1700"/>
           </a:p>
@@ -2053,7 +2040,7 @@
                 </a:solidFill>
                 <a:latin typeface="Aptos"/>
               </a:rPr>
-              <a:t>- Haaland/Odegaard effect on Norway's upset risk</a:t>
+              <a:t>- Almada and Lopez bench options</a:t>
             </a:r>
             <a:endParaRPr lang="en-US" sz="1700"/>
           </a:p>
@@ -2066,7 +2053,7 @@
                 </a:solidFill>
                 <a:latin typeface="Aptos"/>
               </a:rPr>
-              <a:t>- Goalkeeper form in knockout games</a:t>
+              <a:t>- Goalkeeper form under pressure</a:t>
             </a:r>
             <a:endParaRPr lang="en-US" sz="1700"/>
           </a:p>
@@ -2197,7 +2184,7 @@
                 </a:solidFill>
                 <a:latin typeface="Aptos"/>
               </a:rPr>
-              <a:t>1. Update FIFA rankings when the June 2026 list is published.</a:t>
+              <a:t>1. Lock newly completed matches in the model source.</a:t>
             </a:r>
             <a:endParaRPr lang="en-US" sz="1800"/>
           </a:p>
@@ -2210,7 +2197,7 @@
                 </a:solidFill>
                 <a:latin typeface="Aptos"/>
               </a:rPr>
-              <a:t>2. Refresh the player-form modifier after final squads, injuries, and late club matches.</a:t>
+              <a:t>2. Run the SofaScore and prediction-market collectors.</a:t>
             </a:r>
             <a:endParaRPr lang="en-US" sz="1800"/>
           </a:p>
@@ -2223,7 +2210,7 @@
                 </a:solidFill>
                 <a:latin typeface="Aptos"/>
               </a:rPr>
-              <a:t>3. Re-run the notebook cells from top to bottom.</a:t>
+              <a:t>3. Regenerate and execute the notebook.</a:t>
             </a:r>
             <a:endParaRPr lang="en-US" sz="1800"/>
           </a:p>
@@ -2236,7 +2223,7 @@
                 </a:solidFill>
                 <a:latin typeface="Aptos"/>
               </a:rPr>
-              <a:t>4. Rebuild this deck from the current notebook outputs if the bracket path changes.</a:t>
+              <a:t>4. Rebuild tables, site, README assets, and this deck from the executed outputs.</a:t>
             </a:r>
             <a:endParaRPr lang="en-US" sz="1800"/>
           </a:p>
@@ -2277,7 +2264,7 @@
                 </a:solidFill>
                 <a:latin typeface="Aptos"/>
               </a:rPr>
-              <a:t>Best next enhancement: add a player-form input table for recent ratings, minutes, goals/assists, defensive actions, goalkeeper saves, and injury status.</a:t>
+              <a:t>Current coverage: 100 completed matches with direct player ratings, minutes, team statistics, and shot maps.</a:t>
             </a:r>
             <a:endParaRPr lang="en-US" sz="1700"/>
           </a:p>

</xml_diff>